<commit_message>
A6: the HTML deck with every figure checked against the claims register and its PDF and PPTX, the architecture diagram, the brief on the tokens and the six steps, the A1 poster, and one term across the demo's records
</commit_message>
<xml_diff>
--- a/docs/presentation/sample-CS310-week-6-teaching-pack.pptx
+++ b/docs/presentation/sample-CS310-week-6-teaching-pack.pptx
@@ -1302,7 +1302,7 @@
     <p:bg>
       <p:bgPr>
         <a:solidFill>
-          <a:srgbClr val="14213D"/>
+          <a:srgbClr val="0F2A20"/>
         </a:solidFill>
       </p:bgPr>
     </p:bg>
@@ -1349,11 +1349,11 @@
             <a:r>
               <a:rPr lang="en-US" sz="3400" b="1" dirty="0">
                 <a:solidFill>
-                  <a:srgbClr val="FBFBF8"/>
+                  <a:srgbClr val="FFFFFF"/>
                 </a:solidFill>
-                <a:latin typeface="Georgia" pitchFamily="34" charset="0"/>
-                <a:ea typeface="Georgia" pitchFamily="34" charset="-122"/>
-                <a:cs typeface="Georgia" pitchFamily="34" charset="-120"/>
+                <a:latin typeface="Calibri" pitchFamily="34" charset="0"/>
+                <a:ea typeface="Calibri" pitchFamily="34" charset="-122"/>
+                <a:cs typeface="Calibri" pitchFamily="34" charset="-120"/>
               </a:rPr>
               <a:t>CS310 week 6: Dashboard lab: from a messy dataset to a decision</a:t>
             </a:r>
@@ -1390,7 +1390,7 @@
             <a:r>
               <a:rPr lang="en-US" sz="2000" dirty="0">
                 <a:solidFill>
-                  <a:srgbClr val="BFD8D5"/>
+                  <a:srgbClr val="B9CDBF"/>
                 </a:solidFill>
                 <a:latin typeface="Calibri" pitchFamily="34" charset="0"/>
                 <a:ea typeface="Calibri" pitchFamily="34" charset="-122"/>
@@ -1431,13 +1431,13 @@
             <a:r>
               <a:rPr lang="en-US" sz="1400" dirty="0">
                 <a:solidFill>
-                  <a:srgbClr val="BFD8D5"/>
+                  <a:srgbClr val="B9CDBF"/>
                 </a:solidFill>
                 <a:latin typeface="Calibri" pitchFamily="34" charset="0"/>
                 <a:ea typeface="Calibri" pitchFamily="34" charset="-122"/>
                 <a:cs typeface="Calibri" pitchFamily="34" charset="-120"/>
               </a:rPr>
-              <a:t>Prepared by Dr Sobri on 2026-10-08T23:57:19.297Z.</a:t>
+              <a:t>Prepared by Dr Sobri on 2026-07-01T10:00:00Z.</a:t>
             </a:r>
             <a:endParaRPr lang="en-US" sz="1400" dirty="0"/>
           </a:p>
@@ -1448,7 +1448,7 @@
             <a:r>
               <a:rPr lang="en-US" sz="1400" dirty="0">
                 <a:solidFill>
-                  <a:srgbClr val="BFD8D5"/>
+                  <a:srgbClr val="B9CDBF"/>
                 </a:solidFill>
                 <a:latin typeface="Calibri" pitchFamily="34" charset="0"/>
                 <a:ea typeface="Calibri" pitchFamily="34" charset="-122"/>
@@ -1487,7 +1487,7 @@
             <a:r>
               <a:rPr lang="en-US" sz="1000" dirty="0">
                 <a:solidFill>
-                  <a:srgbClr val="9AD4A8"/>
+                  <a:srgbClr val="B9CDBF"/>
                 </a:solidFill>
                 <a:latin typeface="Calibri" pitchFamily="34" charset="0"/>
                 <a:ea typeface="Calibri" pitchFamily="34" charset="-122"/>
@@ -1513,7 +1513,7 @@
     <p:bg>
       <p:bgPr>
         <a:solidFill>
-          <a:srgbClr val="FBFBF8"/>
+          <a:srgbClr val="FFFFFF"/>
         </a:solidFill>
       </p:bgPr>
     </p:bg>
@@ -1560,11 +1560,11 @@
             <a:r>
               <a:rPr lang="en-US" sz="2600" b="1" dirty="0">
                 <a:solidFill>
-                  <a:srgbClr val="14213D"/>
+                  <a:srgbClr val="0F2A20"/>
                 </a:solidFill>
-                <a:latin typeface="Georgia" pitchFamily="34" charset="0"/>
-                <a:ea typeface="Georgia" pitchFamily="34" charset="-122"/>
-                <a:cs typeface="Georgia" pitchFamily="34" charset="-120"/>
+                <a:latin typeface="Calibri" pitchFamily="34" charset="0"/>
+                <a:ea typeface="Calibri" pitchFamily="34" charset="-122"/>
+                <a:cs typeface="Calibri" pitchFamily="34" charset="-120"/>
               </a:rPr>
               <a:t>Learning outcomes for this session</a:t>
             </a:r>
@@ -1605,13 +1605,13 @@
             <a:r>
               <a:rPr lang="en-US" sz="1400" dirty="0">
                 <a:solidFill>
-                  <a:srgbClr val="1F2937"/>
+                  <a:srgbClr val="0F2A20"/>
                 </a:solidFill>
                 <a:latin typeface="Calibri" pitchFamily="34" charset="0"/>
                 <a:ea typeface="Calibri" pitchFamily="34" charset="-122"/>
                 <a:cs typeface="Calibri" pitchFamily="34" charset="-120"/>
               </a:rPr>
-              <a:t>CLO5: Data visualisation</a:t>
+              <a:t>CLO5: Data visualisation with dashboards that answer a stakeholder's question</a:t>
             </a:r>
             <a:endParaRPr lang="en-US" sz="1400" dirty="0"/>
           </a:p>
@@ -1644,7 +1644,7 @@
             <a:r>
               <a:rPr lang="en-US" sz="900" dirty="0">
                 <a:solidFill>
-                  <a:srgbClr val="6A7179"/>
+                  <a:srgbClr val="4E6258"/>
                 </a:solidFill>
                 <a:latin typeface="Calibri" pitchFamily="34" charset="0"/>
                 <a:ea typeface="Calibri" pitchFamily="34" charset="-122"/>
@@ -1670,7 +1670,7 @@
     <p:bg>
       <p:bgPr>
         <a:solidFill>
-          <a:srgbClr val="FBFBF8"/>
+          <a:srgbClr val="FFFFFF"/>
         </a:solidFill>
       </p:bgPr>
     </p:bg>
@@ -1717,11 +1717,11 @@
             <a:r>
               <a:rPr lang="en-US" sz="2600" b="1" dirty="0">
                 <a:solidFill>
-                  <a:srgbClr val="14213D"/>
+                  <a:srgbClr val="0F2A20"/>
                 </a:solidFill>
-                <a:latin typeface="Georgia" pitchFamily="34" charset="0"/>
-                <a:ea typeface="Georgia" pitchFamily="34" charset="-122"/>
-                <a:cs typeface="Georgia" pitchFamily="34" charset="-120"/>
+                <a:latin typeface="Calibri" pitchFamily="34" charset="0"/>
+                <a:ea typeface="Calibri" pitchFamily="34" charset="-122"/>
+                <a:cs typeface="Calibri" pitchFamily="34" charset="-120"/>
               </a:rPr>
               <a:t>Why this matters: what employers ask for</a:t>
             </a:r>
@@ -1762,13 +1762,13 @@
             <a:r>
               <a:rPr lang="en-US" sz="1400" dirty="0">
                 <a:solidFill>
-                  <a:srgbClr val="1F2937"/>
+                  <a:srgbClr val="0F2A20"/>
                 </a:solidFill>
                 <a:latin typeface="Calibri" pitchFamily="34" charset="0"/>
                 <a:ea typeface="Calibri" pitchFamily="34" charset="-122"/>
                 <a:cs typeface="Calibri" pitchFamily="34" charset="-120"/>
               </a:rPr>
-              <a:t>dashboards: 4 of 5 reviewed postings (37.6% to 96.4%). Coverage today: Introduced; target: Practised.</a:t>
+              <a:t>dashboards: 5 of 9 reviewed postings (26.7% to 81.1%). Coverage today: Introduced; target: Practised.</a:t>
             </a:r>
             <a:endParaRPr lang="en-US" sz="1400" dirty="0"/>
           </a:p>
@@ -1782,7 +1782,7 @@
             <a:r>
               <a:rPr lang="en-US" sz="1400" dirty="0">
                 <a:solidFill>
-                  <a:srgbClr val="6A7179"/>
+                  <a:srgbClr val="4E6258"/>
                 </a:solidFill>
                 <a:latin typeface="Calibri" pitchFamily="34" charset="0"/>
                 <a:ea typeface="Calibri" pitchFamily="34" charset="-122"/>
@@ -1821,7 +1821,7 @@
             <a:r>
               <a:rPr lang="en-US" sz="900" dirty="0">
                 <a:solidFill>
-                  <a:srgbClr val="6A7179"/>
+                  <a:srgbClr val="4E6258"/>
                 </a:solidFill>
                 <a:latin typeface="Calibri" pitchFamily="34" charset="0"/>
                 <a:ea typeface="Calibri" pitchFamily="34" charset="-122"/>
@@ -1847,7 +1847,7 @@
     <p:bg>
       <p:bgPr>
         <a:solidFill>
-          <a:srgbClr val="FBFBF8"/>
+          <a:srgbClr val="FFFFFF"/>
         </a:solidFill>
       </p:bgPr>
     </p:bg>
@@ -1894,11 +1894,11 @@
             <a:r>
               <a:rPr lang="en-US" sz="2600" b="1" dirty="0">
                 <a:solidFill>
-                  <a:srgbClr val="14213D"/>
+                  <a:srgbClr val="0F2A20"/>
                 </a:solidFill>
-                <a:latin typeface="Georgia" pitchFamily="34" charset="0"/>
-                <a:ea typeface="Georgia" pitchFamily="34" charset="-122"/>
-                <a:cs typeface="Georgia" pitchFamily="34" charset="-120"/>
+                <a:latin typeface="Calibri" pitchFamily="34" charset="0"/>
+                <a:ea typeface="Calibri" pitchFamily="34" charset="-122"/>
+                <a:cs typeface="Calibri" pitchFamily="34" charset="-120"/>
               </a:rPr>
               <a:t>Learning activity</a:t>
             </a:r>
@@ -1935,7 +1935,7 @@
             <a:r>
               <a:rPr lang="en-US" sz="1600" dirty="0">
                 <a:solidFill>
-                  <a:srgbClr val="1F2937"/>
+                  <a:srgbClr val="0F2A20"/>
                 </a:solidFill>
                 <a:latin typeface="Calibri" pitchFamily="34" charset="0"/>
                 <a:ea typeface="Calibri" pitchFamily="34" charset="-122"/>
@@ -1974,7 +1974,7 @@
             <a:r>
               <a:rPr lang="en-US" sz="900" dirty="0">
                 <a:solidFill>
-                  <a:srgbClr val="6A7179"/>
+                  <a:srgbClr val="4E6258"/>
                 </a:solidFill>
                 <a:latin typeface="Calibri" pitchFamily="34" charset="0"/>
                 <a:ea typeface="Calibri" pitchFamily="34" charset="-122"/>
@@ -2000,7 +2000,7 @@
     <p:bg>
       <p:bgPr>
         <a:solidFill>
-          <a:srgbClr val="FBFBF8"/>
+          <a:srgbClr val="FFFFFF"/>
         </a:solidFill>
       </p:bgPr>
     </p:bg>
@@ -2047,11 +2047,11 @@
             <a:r>
               <a:rPr lang="en-US" sz="2600" b="1" dirty="0">
                 <a:solidFill>
-                  <a:srgbClr val="14213D"/>
+                  <a:srgbClr val="0F2A20"/>
                 </a:solidFill>
-                <a:latin typeface="Georgia" pitchFamily="34" charset="0"/>
-                <a:ea typeface="Georgia" pitchFamily="34" charset="-122"/>
-                <a:cs typeface="Georgia" pitchFamily="34" charset="-120"/>
+                <a:latin typeface="Calibri" pitchFamily="34" charset="0"/>
+                <a:ea typeface="Calibri" pitchFamily="34" charset="-122"/>
+                <a:cs typeface="Calibri" pitchFamily="34" charset="-120"/>
               </a:rPr>
               <a:t>Check for understanding</a:t>
             </a:r>
@@ -2088,7 +2088,7 @@
             <a:r>
               <a:rPr lang="en-US" sz="1600" dirty="0">
                 <a:solidFill>
-                  <a:srgbClr val="1F2937"/>
+                  <a:srgbClr val="0F2A20"/>
                 </a:solidFill>
                 <a:latin typeface="Calibri" pitchFamily="34" charset="0"/>
                 <a:ea typeface="Calibri" pitchFamily="34" charset="-122"/>
@@ -2127,7 +2127,7 @@
             <a:r>
               <a:rPr lang="en-US" sz="900" dirty="0">
                 <a:solidFill>
-                  <a:srgbClr val="6A7179"/>
+                  <a:srgbClr val="4E6258"/>
                 </a:solidFill>
                 <a:latin typeface="Calibri" pitchFamily="34" charset="0"/>
                 <a:ea typeface="Calibri" pitchFamily="34" charset="-122"/>
@@ -2153,7 +2153,7 @@
     <p:bg>
       <p:bgPr>
         <a:solidFill>
-          <a:srgbClr val="FBFBF8"/>
+          <a:srgbClr val="FFFFFF"/>
         </a:solidFill>
       </p:bgPr>
     </p:bg>
@@ -2200,11 +2200,11 @@
             <a:r>
               <a:rPr lang="en-US" sz="2600" b="1" dirty="0">
                 <a:solidFill>
-                  <a:srgbClr val="14213D"/>
+                  <a:srgbClr val="0F2A20"/>
                 </a:solidFill>
-                <a:latin typeface="Georgia" pitchFamily="34" charset="0"/>
-                <a:ea typeface="Georgia" pitchFamily="34" charset="-122"/>
-                <a:cs typeface="Georgia" pitchFamily="34" charset="-120"/>
+                <a:latin typeface="Calibri" pitchFamily="34" charset="0"/>
+                <a:ea typeface="Calibri" pitchFamily="34" charset="-122"/>
+                <a:cs typeface="Calibri" pitchFamily="34" charset="-120"/>
               </a:rPr>
               <a:t>Resources and references</a:t>
             </a:r>
@@ -2241,13 +2241,13 @@
             <a:r>
               <a:rPr lang="en-US" sz="1600" dirty="0">
                 <a:solidFill>
-                  <a:srgbClr val="1F2937"/>
+                  <a:srgbClr val="0F2A20"/>
                 </a:solidFill>
                 <a:latin typeface="Calibri" pitchFamily="34" charset="0"/>
                 <a:ea typeface="Calibri" pitchFamily="34" charset="-122"/>
                 <a:cs typeface="Calibri" pitchFamily="34" charset="-120"/>
               </a:rPr>
-              <a:t>Course notes chapter 6; the postings quoted in this pack.</a:t>
+              <a:t>No resources recorded.</a:t>
             </a:r>
             <a:endParaRPr lang="en-US" sz="1600" dirty="0"/>
           </a:p>
@@ -2280,7 +2280,7 @@
             <a:r>
               <a:rPr lang="en-US" sz="900" dirty="0">
                 <a:solidFill>
-                  <a:srgbClr val="6A7179"/>
+                  <a:srgbClr val="4E6258"/>
                 </a:solidFill>
                 <a:latin typeface="Calibri" pitchFamily="34" charset="0"/>
                 <a:ea typeface="Calibri" pitchFamily="34" charset="-122"/>

</xml_diff>